<commit_message>
Say what the train is in the workshop's railway analogy
The material spoke of the train ("composição", "trem vistoriado") without
saying what it stands for. The train is the product version, the
contract's text in the other analogy; the tracks and stations are its
path and record. Slide 10, the facilitator script and the pocket card
now say so.

Co-Authored-By: Claude Opus 5.5 <noreply@anthropic.com>
Claude-Session: https://claude.ai/code/session_017z8RJ8WcvgeWy5Kw7goBXT
</commit_message>
<xml_diff>
--- a/treinamento/oficina-nos-trilhos/1-slides-nos-trilhos.pptx
+++ b/treinamento/oficina-nos-trilhos/1-slides-nos-trilhos.pptx
@@ -145,14 +145,14 @@
   <p:extLst>
     <p:ext uri="{521415D9-36F7-43E2-AB2F-B90AF26B5E84}">
       <p14:sectionLst xmlns:p14="http://schemas.microsoft.com/office/powerpoint/2010/main">
-        <p14:section name="Abertura" id="{7d82fdd7-4328-2525-bc36-08d62b23bae3}">
+        <p14:section name="Abertura" id="{0f1eee33-1d9e-1284-d944-f94c3e0d43cb}">
           <p14:sldIdLst>
             <p14:sldId id="256"/>
             <p14:sldId id="257"/>
             <p14:sldId id="258"/>
           </p14:sldIdLst>
         </p14:section>
-        <p14:section name="1 · Por que versionar" id="{026c23da-b613-9a6c-8e1e-9d0c477cd70d}">
+        <p14:section name="1 · Por que versionar" id="{a9317fb6-166e-bcb0-c723-fb36636e09f1}">
           <p14:sldIdLst>
             <p14:sldId id="259"/>
             <p14:sldId id="260"/>
@@ -161,7 +161,7 @@
             <p14:sldId id="263"/>
           </p14:sldIdLst>
         </p14:section>
-        <p14:section name="2 · A malha ferroviária" id="{2f1688ed-84d4-35ad-67d2-79b216fa7a65}">
+        <p14:section name="2 · A malha ferroviária" id="{8936bf3c-7deb-60fa-dade-5ed06f33f1ac}">
           <p14:sldIdLst>
             <p14:sldId id="264"/>
             <p14:sldId id="265"/>
@@ -174,7 +174,7 @@
             <p14:sldId id="272"/>
           </p14:sldIdLst>
         </p14:section>
-        <p14:section name="3 · Os tipos de merge" id="{a71d1ecd-6ae7-eb89-a5c8-48f542094393}">
+        <p14:section name="3 · Os tipos de merge" id="{ca9306e9-1e0d-fb52-2ae2-011b27db420e}">
           <p14:sldIdLst>
             <p14:sldId id="273"/>
             <p14:sldId id="274"/>
@@ -189,7 +189,7 @@
             <p14:sldId id="283"/>
           </p14:sldIdLst>
         </p14:section>
-        <p14:section name="4 · A viagem no Modelo VIC" id="{35680c6f-6393-3a78-fea1-00c044c5fbad}">
+        <p14:section name="4 · A viagem no Modelo VIC" id="{d270aba3-2225-f75f-2417-8a341a7452b3}">
           <p14:sldIdLst>
             <p14:sldId id="284"/>
             <p14:sldId id="285"/>
@@ -200,7 +200,7 @@
             <p14:sldId id="290"/>
           </p14:sldIdLst>
         </p14:section>
-        <p14:section name="Fechamento" id="{d74e4ad6-3279-1502-5f0a-eb0db8655cf0}">
+        <p14:section name="Fechamento" id="{9b022b9c-0fdb-0b8f-7577-152aca066bbe}">
           <p14:sldIdLst>
             <p14:sldId id="291"/>
             <p14:sldId id="292"/>
@@ -700,7 +700,7 @@
           <a:p>
             <a:r>
               <a:rPr lang="en-US" dirty="0"/>
-              <a:t>Leia o desenho da esquerda para a direita. A linha azul é um trilho; cada bolinha é uma estação, um commit. Em B, sai um desvio: alguém foi trabalhar separado. F1 e F2 são as paradas desse trabalho. Em M, o desvio volta: isso é o merge. O tempo corre para a direita; C veio depois de tudo.</a:t>
+              <a:t>Leia o desenho da esquerda para a direita. A linha azul é um trilho; cada bolinha é uma estação, um commit. Em B, sai um desvio: alguém foi trabalhar separado. F1 e F2 são as paradas desse trabalho. Em M, o desvio volta: isso é o merge. O tempo corre para a direita; C veio depois de tudo. Feche com a frase de baixo: o trem, a composição, é a versão do produto, o que no contrato é o texto. É ele que se monta na develop, para na vistoria e entra em operação na main.</a:t>
             </a:r>
             <a:endParaRPr lang="en-US" dirty="0"/>
           </a:p>
@@ -6528,8 +6528,8 @@
         </p:blipFill>
         <p:spPr>
           <a:xfrm>
-            <a:off x="1463040" y="1325880"/>
-            <a:ext cx="9235440" cy="3034502"/>
+            <a:off x="1691640" y="1325880"/>
+            <a:ext cx="8778240" cy="2884279"/>
           </a:xfrm>
           <a:prstGeom prst="rect">
             <a:avLst/>
@@ -6539,6 +6539,53 @@
       <p:sp>
         <p:nvSpPr>
           <p:cNvPr id="5" name="Text 2"/>
+          <p:cNvSpPr txBox="1"/>
+          <p:nvPr/>
+        </p:nvSpPr>
+        <p:spPr>
+          <a:xfrm>
+            <a:off x="822960" y="4114800"/>
+            <a:ext cx="10515600" cy="548640"/>
+          </a:xfrm>
+          <a:prstGeom prst="rect">
+            <a:avLst/>
+          </a:prstGeom>
+          <a:noFill/>
+          <a:ln/>
+        </p:spPr>
+        <p:txBody>
+          <a:bodyPr wrap="square" lIns="0" tIns="0" rIns="0" bIns="0" rtlCol="0" anchor="ctr"/>
+          <a:lstStyle/>
+          <a:p>
+            <a:pPr algn="ctr" indent="0" marL="0">
+              <a:buNone/>
+            </a:pPr>
+            <a:r>
+              <a:rPr lang="en-US" sz="1400" b="1" dirty="0">
+                <a:solidFill>
+                  <a:schemeClr val="accent1"/>
+                </a:solidFill>
+              </a:rPr>
+              <a:t>E o trem? </a:t>
+            </a:r>
+            <a:pPr algn="ctr" indent="0" marL="0">
+              <a:buNone/>
+            </a:pPr>
+            <a:r>
+              <a:rPr lang="en-US" sz="1400" dirty="0">
+                <a:solidFill>
+                  <a:schemeClr val="tx1"/>
+                </a:solidFill>
+              </a:rPr>
+              <a:t>A composição é a versão do produto; no contrato, o texto. Os trilhos e as estações são o caminho e o registro dela.</a:t>
+            </a:r>
+            <a:endParaRPr lang="en-US" sz="1400" dirty="0"/>
+          </a:p>
+        </p:txBody>
+      </p:sp>
+      <p:sp>
+        <p:nvSpPr>
+          <p:cNvPr id="6" name="Text 3"/>
           <p:cNvSpPr txBox="1"/>
           <p:nvPr/>
         </p:nvSpPr>
@@ -6588,7 +6635,7 @@
       </p:sp>
       <p:sp>
         <p:nvSpPr>
-          <p:cNvPr id="6" name="Text 3"/>
+          <p:cNvPr id="7" name="Text 4"/>
           <p:cNvSpPr txBox="1"/>
           <p:nvPr/>
         </p:nvSpPr>
@@ -6635,7 +6682,7 @@
       </p:sp>
       <p:sp>
         <p:nvSpPr>
-          <p:cNvPr id="7" name="Text 4"/>
+          <p:cNvPr id="8" name="Text 5"/>
           <p:cNvSpPr txBox="1"/>
           <p:nvPr/>
         </p:nvSpPr>
@@ -6682,7 +6729,7 @@
       </p:sp>
       <p:sp>
         <p:nvSpPr>
-          <p:cNvPr id="8" name="Text 5"/>
+          <p:cNvPr id="9" name="Text 6"/>
           <p:cNvSpPr txBox="1"/>
           <p:nvPr/>
         </p:nvSpPr>
@@ -6732,7 +6779,7 @@
       </p:sp>
       <p:sp>
         <p:nvSpPr>
-          <p:cNvPr id="9" name="Text 6"/>
+          <p:cNvPr id="10" name="Text 7"/>
           <p:cNvSpPr txBox="1"/>
           <p:nvPr/>
         </p:nvSpPr>
@@ -6779,7 +6826,7 @@
       </p:sp>
       <p:sp>
         <p:nvSpPr>
-          <p:cNvPr id="10" name="Text 7"/>
+          <p:cNvPr id="11" name="Text 8"/>
           <p:cNvSpPr txBox="1"/>
           <p:nvPr/>
         </p:nvSpPr>
@@ -6826,7 +6873,7 @@
       </p:sp>
       <p:sp>
         <p:nvSpPr>
-          <p:cNvPr id="11" name="Text 8"/>
+          <p:cNvPr id="12" name="Text 9"/>
           <p:cNvSpPr txBox="1"/>
           <p:nvPr/>
         </p:nvSpPr>
@@ -6876,7 +6923,7 @@
       </p:sp>
       <p:sp>
         <p:nvSpPr>
-          <p:cNvPr id="12" name="Text 9"/>
+          <p:cNvPr id="13" name="Text 10"/>
           <p:cNvSpPr txBox="1"/>
           <p:nvPr/>
         </p:nvSpPr>
@@ -6923,7 +6970,7 @@
       </p:sp>
       <p:sp>
         <p:nvSpPr>
-          <p:cNvPr id="13" name="Text 10"/>
+          <p:cNvPr id="14" name="Text 11"/>
           <p:cNvSpPr txBox="1"/>
           <p:nvPr/>
         </p:nvSpPr>
@@ -6970,7 +7017,7 @@
       </p:sp>
       <p:sp>
         <p:nvSpPr>
-          <p:cNvPr id="14" name="Text 11"/>
+          <p:cNvPr id="15" name="Text 12"/>
           <p:cNvSpPr txBox="1"/>
           <p:nvPr/>
         </p:nvSpPr>
@@ -7020,7 +7067,7 @@
       </p:sp>
       <p:sp>
         <p:nvSpPr>
-          <p:cNvPr id="15" name="Text 12"/>
+          <p:cNvPr id="16" name="Text 13"/>
           <p:cNvSpPr txBox="1"/>
           <p:nvPr/>
         </p:nvSpPr>
@@ -7067,7 +7114,7 @@
       </p:sp>
       <p:sp>
         <p:nvSpPr>
-          <p:cNvPr id="16" name="Text 13"/>
+          <p:cNvPr id="17" name="Text 14"/>
           <p:cNvSpPr txBox="1"/>
           <p:nvPr/>
         </p:nvSpPr>

</xml_diff>

<commit_message>
Show the feature wagon reaching release in the train map
In the full map the release composition lacked the Cartões wagon being
built in the feature branch, and the commercial train already had it.
Now the commercial train has only Pix and Login, the yard keeps an empty
slot for Cartões, and the release carries Cartões, Pix and Login. The
speaker notes and the facilitator script say so.

Co-Authored-By: Claude Opus 5.5 <noreply@anthropic.com>
Claude-Session: https://claude.ai/code/session_017z8RJ8WcvgeWy5Kw7goBXT
</commit_message>
<xml_diff>
--- a/treinamento/oficina-nos-trilhos/1-slides-nos-trilhos.pptx
+++ b/treinamento/oficina-nos-trilhos/1-slides-nos-trilhos.pptx
@@ -147,14 +147,14 @@
   <p:extLst>
     <p:ext uri="{521415D9-36F7-43E2-AB2F-B90AF26B5E84}">
       <p14:sectionLst xmlns:p14="http://schemas.microsoft.com/office/powerpoint/2010/main">
-        <p14:section name="Abertura" id="{8791a8cd-6c94-e50e-034b-d25f262d9e53}">
+        <p14:section name="Abertura" id="{a3c71183-09ab-db9c-2bb9-c135ff214f23}">
           <p14:sldIdLst>
             <p14:sldId id="256"/>
             <p14:sldId id="257"/>
             <p14:sldId id="258"/>
           </p14:sldIdLst>
         </p14:section>
-        <p14:section name="1 · O trem e os trilhos" id="{aa0cb884-cec0-e8f9-3353-9b79572880ea}">
+        <p14:section name="1 · O trem e os trilhos" id="{5bed58e2-7539-950d-09af-011414b46f09}">
           <p14:sldIdLst>
             <p14:sldId id="259"/>
             <p14:sldId id="260"/>
@@ -169,7 +169,7 @@
             <p14:sldId id="269"/>
           </p14:sldIdLst>
         </p14:section>
-        <p14:section name="2 · O contrato" id="{920cd375-2b96-bed3-3a5f-a20d1aacee76}">
+        <p14:section name="2 · O contrato" id="{e0960e33-50f7-d219-2fc2-37a95420a114}">
           <p14:sldIdLst>
             <p14:sldId id="270"/>
             <p14:sldId id="271"/>
@@ -178,7 +178,7 @@
             <p14:sldId id="274"/>
           </p14:sldIdLst>
         </p14:section>
-        <p14:section name="3 · Os tipos de merge" id="{85ef5357-f991-1c3f-e7c1-030194bd3678}">
+        <p14:section name="3 · Os tipos de merge" id="{58a51b47-0d36-b2b2-0efc-c015b152e38f}">
           <p14:sldIdLst>
             <p14:sldId id="275"/>
             <p14:sldId id="276"/>
@@ -193,7 +193,7 @@
             <p14:sldId id="285"/>
           </p14:sldIdLst>
         </p14:section>
-        <p14:section name="4 · Versões e as regras do Modelo VIC" id="{0a01d10e-8cc7-a932-46f2-3a204188b7c8}">
+        <p14:section name="4 · Versões e as regras do Modelo VIC" id="{25c3758a-c9ce-f8eb-ceb3-2f9a29475e81}">
           <p14:sldIdLst>
             <p14:sldId id="286"/>
             <p14:sldId id="287"/>
@@ -204,7 +204,7 @@
             <p14:sldId id="292"/>
           </p14:sldIdLst>
         </p14:section>
-        <p14:section name="Fechamento" id="{7dbff8db-5163-c2f6-4c57-7e5ed93c75f4}">
+        <p14:section name="Fechamento" id="{2f969b45-369e-aaaf-0861-a81a6ff533d1}">
           <p14:sldIdLst>
             <p14:sldId id="293"/>
             <p14:sldId id="294"/>
@@ -704,7 +704,7 @@
           <a:p>
             <a:r>
               <a:rPr lang="en-US" dirty="0"/>
-              <a:t>Percorra a malha devagar. Em cima, a main: o trem comercial, com passageiros. Embaixo, a develop: o pátio, montando a próxima composição; o vagão tracejado é o lugar do que ainda está na oficina. Na feature, o vagão Cartões é construído e volta para o pátio. Quando a composição do pátio fica pronta, vai inteira para a vistoria, a release; aprovada, entra na linha comercial e também volta para o pátio. Quando um vagão do trem comercial dá defeito, ele vai para o desvio de emergência, o hotfix, e o conserto volta para o trem comercial e para o pátio.</a:t>
+              <a:t>Percorra a malha devagar. Em cima, a main: o trem comercial, com passageiros. Embaixo, a develop: o pátio, montando a próxima composição; o vagão tracejado é o lugar do que ainda está na oficina. Na feature, o vagão Cartões é construído e volta para o pátio, onde ocupa o lugar tracejado. Quando a composição do pátio fica pronta, vai inteira para a vistoria, a release, já com o Cartões; aprovada, entra na linha comercial e também volta para o pátio. Repare que o trem comercial ainda não tem o Cartões: ele só chega aos passageiros pela vistoria. Quando um vagão do trem comercial dá defeito, ele vai para o desvio de emergência, o hotfix, e o conserto volta para o trem comercial e para o pátio.</a:t>
             </a:r>
             <a:endParaRPr lang="en-US" dirty="0"/>
           </a:p>
@@ -6687,7 +6687,7 @@
         <p:spPr>
           <a:xfrm>
             <a:off x="868680" y="1188720"/>
-            <a:ext cx="10424160" cy="4738255"/>
+            <a:ext cx="10424160" cy="4493172"/>
           </a:xfrm>
           <a:prstGeom prst="rect">
             <a:avLst/>

</xml_diff>